<commit_message>
Enforce prompt truncation, paraphrase gating, docs
Add explicit prompt truncation to preserve the SFT template and avoid generate() cropping the template off the front: implement _truncate_question and _no_context_prompt, update _context_prompt and build_prompt to use them. Add comprehensive tests (TestQuestionFitsTheBlockBudget) to cover oversized questions and boundary cases. Clarify README and video script: publish Hugging Face checkpoint link, document paraphrase-only grounding, best-of-N and nucleus sampling choices, and closed-book behavior. Also include an updated PPTX binary.
</commit_message>
<xml_diff>
--- a/Tern_AI_Technical_Overview.pptx
+++ b/Tern_AI_Technical_Overview.pptx
@@ -3842,7 +3842,7 @@
               </a:defRPr>
             </a:pPr>
             <a:r>
-              <a:t>•  A single desktop application (tkinter) to train, resume, and converse with the model</a:t>
+              <a:t>•  A single desktop application (tkinter) to train, resume, and converse with the model, closed book or grounded, picked per question</a:t>
             </a:r>
           </a:p>
         </p:txBody>
@@ -4043,7 +4043,7 @@
               </a:defRPr>
             </a:pPr>
             <a:r>
-              <a:t>A chat loop that grounds answers in real retrieved text, dispatches real tools for real computation, and falls back to a live search only when the model's own training says it does not know,</a:t>
+              <a:t>A chat loop that always generates its own answer, grounded in real retrieved text or a live search when the model doesn't know, but never a copy of either,</a:t>
             </a:r>
           </a:p>
           <a:p>
@@ -4059,7 +4059,7 @@
               </a:defRPr>
             </a:pPr>
             <a:r>
-              <a:t>every answer tagged with exactly where it came from.</a:t>
+              <a:t>every answer tagged with exactly where it came from. The finished checkpoint is public on Hugging Face for anyone who wants to skip training and just talk to it.</a:t>
             </a:r>
           </a:p>
         </p:txBody>
@@ -5795,7 +5795,7 @@
               </a:defRPr>
             </a:pPr>
             <a:r>
-              <a:t>A calculator result or a live search hit is already correct. A second generation pass could only add a chance for a small model to say something wrong on top of a right answer, so the real tool output is printed directly.</a:t>
+              <a:t>A calculator result is already correct. A second generation pass could only add a chance for a small model to say something wrong on top of a right answer, so the real tool output is printed directly.</a:t>
             </a:r>
           </a:p>
           <a:p>
@@ -5811,7 +5811,7 @@
               </a:defRPr>
             </a:pPr>
             <a:r>
-              <a:t>The same rule applies to live search fallback:</a:t>
+              <a:t>Live search is different: the result is fed back in, not printed directly.</a:t>
             </a:r>
           </a:p>
           <a:p>
@@ -5827,7 +5827,7 @@
               </a:defRPr>
             </a:pPr>
             <a:r>
-              <a:t>when the model's own training signals it does not know an answer, a real DuckDuckGo result is shown as is, tagged as a live search result, never generated text.</a:t>
+              <a:t>When the model's own training signals it does not know an answer, a real DuckDuckGo result is fed to the model as context and it generates the real answer from that, tagged as AI generated, so the visible answer is always the model's own words, whichever source grounded it.</a:t>
             </a:r>
           </a:p>
         </p:txBody>

</xml_diff>